<commit_message>
India Chem 2026: final revisions to v2 deck per team review
Title reframed to early fault detection (no proven-prediction claim);
slide 2 shows how the Rs 1.4 crore figure is built; slide 3 shows the
weighted-score arithmetic behind 4.3/5; slide 4 notes the pilot tests
the model on real plant data; slide 6 KPI gauges explain what the 70%
detection and 14-day notice targets mean; references renumbered so
citations read 1 to 11 in order on slide 8 and updated across all
slides; speaker notes and research log aligned.

Co-Authored-By: Claude Fable 5 <noreply@anthropic.com>
Claude-Session: https://claude.ai/code/session_01CciExH8qdRbvwTxHjioQBB
</commit_message>
<xml_diff>
--- a/india-chem-2026/deck/India_Chem_2026_NITW_Raunak_Anushriya_v2.pptx
+++ b/india-chem-2026/deck/India_Chem_2026_NITW_Raunak_Anushriya_v2.pptx
@@ -509,7 +509,7 @@
           <a:p>
             <a:r>
               <a:rPr lang="en-US" dirty="0"/>
-              <a:t>Good morning. We are Raunak Jain, mechanical engineering, and Anushriya Bhattacharya, chemical engineering, from NIT Warangal. Our proposal is NAADI, a predictive maintenance system for the critical pumps of a chemical plant. The idea in one sentence: continuous vibration sensing on a plant's 25 most failure-prone pumps, with interpretable machine learning that drafts work orders for the reliability engineer, while all data and models stay on the plant's own network. We are proposing a six-month pilot. The base-case economics, a public benchmark validation of our prototype, and the pilot design follow in the next seven slides. About 60 seconds.</a:t>
+              <a:t>Good morning. We are Raunak Jain, mechanical engineering, and Anushriya Bhattacharya, chemical engineering, from NIT Warangal. Our proposal is NAADI, our response to the predictive maintenance problem statement: an early fault detection system for the critical pumps of a chemical plant. To be precise about the claim: NAADI does not predict the exact moment a pump will fail. It watches vibration continuously, spots developing faults early, and alerts the reliability engineer with a drafted work order, while all data and models stay on the plant's own network. We are proposing a six-month pilot to test exactly that. The base-case economics, a public benchmark validation of our prototype, and the pilot design follow in the next seven slides. About 60 seconds.</a:t>
             </a:r>
             <a:endParaRPr lang="en-US" dirty="0"/>
           </a:p>
@@ -949,7 +949,7 @@
           <a:p>
             <a:r>
               <a:rPr lang="en-US" dirty="0"/>
-              <a:t>Execution is a six-month pilot with one principle: the system must earn trust before anyone relies on it. Months zero to one build the baseline from the plant's own maintenance records and fix the success criteria together with the plant, so the pass bar is agreed before installation. Month two is installation: wireless sensors magnet-mounted during routine access, no shutdown, permits handled through the plant's normal process. Month three commissions healthy baselines, and months three to six run in shadow mode: alerts are logged and compared weekly with what maintenance actually finds, but no decision depends on them yet. The month-six gate is numeric and is on the slide: seventy percent of confirmed developing faults caught at least fourteen days ahead, at most two false alerts per pump per month, and ninety-five percent data availability. Pass the gate and the system goes live, then scales to other rotating assets and, between months twelve and twenty-four, to a shared deployment across chemical clusters. What we need is one plant partner, the pumps, their history and six months of access. About 75 seconds.</a:t>
+              <a:t>Execution is a six-month pilot with one principle: the system must earn trust before anyone relies on it. Months zero to one build the baseline from the plant's own maintenance records and fix the success criteria together with the plant, so the pass bar is agreed before installation. Month two is installation: wireless sensors magnet-mounted during routine access, no shutdown, permits handled through the plant's normal process. Month three commissions healthy baselines, and months three to six run in shadow mode: alerts are logged and compared weekly with what maintenance actually finds, but no decision depends on them yet. The month-six gate is numeric and is on the slide. In plain terms: of the faults maintenance later confirms, at least seven in ten must have been flagged by NAADI beforehand, with at least fourteen days of notice, which is enough to plan the repair into a scheduled window instead of an emergency stop. Alongside that, at most two false alerts per pump per month, and ninety-five percent data availability. Pass the gate and the system goes live, then scales to other rotating assets and, between months twelve and twenty-four, to a shared deployment across chemical clusters. What we need is one plant partner, the pumps, their history and six months of access. About 75 seconds.</a:t>
             </a:r>
             <a:endParaRPr lang="en-US" dirty="0"/>
           </a:p>
@@ -1641,7 +1641,7 @@
                 <a:ea typeface="Arial" pitchFamily="34" charset="-122"/>
                 <a:cs typeface="Arial" pitchFamily="34" charset="-120"/>
               </a:rPr>
-              <a:t>Plant-owned predictive maintenance for critical pumps</a:t>
+              <a:t>Early fault detection for critical pumps, on the plant's own network</a:t>
             </a:r>
             <a:endParaRPr lang="en-US" sz="2200" dirty="0"/>
           </a:p>
@@ -3119,7 +3119,7 @@
         <p:spPr>
           <a:xfrm>
             <a:off x="571500" y="1618488"/>
-            <a:ext cx="2697480" cy="566928"/>
+            <a:ext cx="2697480" cy="512064"/>
           </a:xfrm>
           <a:prstGeom prst="rect">
             <a:avLst/>
@@ -3143,8 +3143,8 @@
         </p:nvSpPr>
         <p:spPr>
           <a:xfrm>
-            <a:off x="644652" y="1673352"/>
-            <a:ext cx="2551176" cy="475488"/>
+            <a:off x="644652" y="1655064"/>
+            <a:ext cx="2551176" cy="438912"/>
           </a:xfrm>
           <a:prstGeom prst="rect">
             <a:avLst/>
@@ -3185,7 +3185,7 @@
         </p:nvSpPr>
         <p:spPr>
           <a:xfrm>
-            <a:off x="3337560" y="1746504"/>
+            <a:off x="3337560" y="1728216"/>
             <a:ext cx="1234440" cy="365760"/>
           </a:xfrm>
           <a:prstGeom prst="rect">
@@ -3227,8 +3227,8 @@
         </p:nvSpPr>
         <p:spPr>
           <a:xfrm>
-            <a:off x="1920240" y="2185416"/>
-            <a:ext cx="0" cy="146304"/>
+            <a:off x="1920240" y="2130552"/>
+            <a:ext cx="0" cy="128016"/>
           </a:xfrm>
           <a:prstGeom prst="line">
             <a:avLst/>
@@ -3250,8 +3250,8 @@
         </p:nvSpPr>
         <p:spPr>
           <a:xfrm>
-            <a:off x="845820" y="2331720"/>
-            <a:ext cx="2148840" cy="566928"/>
+            <a:off x="845820" y="2258568"/>
+            <a:ext cx="2148840" cy="512064"/>
           </a:xfrm>
           <a:prstGeom prst="rect">
             <a:avLst/>
@@ -3275,8 +3275,8 @@
         </p:nvSpPr>
         <p:spPr>
           <a:xfrm>
-            <a:off x="918972" y="2386584"/>
-            <a:ext cx="2002536" cy="475488"/>
+            <a:off x="918972" y="2295144"/>
+            <a:ext cx="2002536" cy="438912"/>
           </a:xfrm>
           <a:prstGeom prst="rect">
             <a:avLst/>
@@ -3317,7 +3317,7 @@
         </p:nvSpPr>
         <p:spPr>
           <a:xfrm>
-            <a:off x="3337560" y="2459736"/>
+            <a:off x="3337560" y="2368296"/>
             <a:ext cx="1234440" cy="365760"/>
           </a:xfrm>
           <a:prstGeom prst="rect">
@@ -3359,8 +3359,8 @@
         </p:nvSpPr>
         <p:spPr>
           <a:xfrm>
-            <a:off x="1920240" y="2898648"/>
-            <a:ext cx="0" cy="146304"/>
+            <a:off x="1920240" y="2770632"/>
+            <a:ext cx="0" cy="128016"/>
           </a:xfrm>
           <a:prstGeom prst="line">
             <a:avLst/>
@@ -3382,8 +3382,8 @@
         </p:nvSpPr>
         <p:spPr>
           <a:xfrm>
-            <a:off x="1074420" y="3044952"/>
-            <a:ext cx="1691640" cy="566928"/>
+            <a:off x="1074420" y="2898648"/>
+            <a:ext cx="1691640" cy="512064"/>
           </a:xfrm>
           <a:prstGeom prst="rect">
             <a:avLst/>
@@ -3402,8 +3402,8 @@
         </p:nvSpPr>
         <p:spPr>
           <a:xfrm>
-            <a:off x="1147572" y="3099816"/>
-            <a:ext cx="1545336" cy="475488"/>
+            <a:off x="1147572" y="2935224"/>
+            <a:ext cx="1545336" cy="438912"/>
           </a:xfrm>
           <a:prstGeom prst="rect">
             <a:avLst/>
@@ -3444,7 +3444,7 @@
         </p:nvSpPr>
         <p:spPr>
           <a:xfrm>
-            <a:off x="3337560" y="3172968"/>
+            <a:off x="3337560" y="3008376"/>
             <a:ext cx="1234440" cy="365760"/>
           </a:xfrm>
           <a:prstGeom prst="rect">
@@ -3486,8 +3486,8 @@
         </p:nvSpPr>
         <p:spPr>
           <a:xfrm>
-            <a:off x="1920240" y="3611880"/>
-            <a:ext cx="0" cy="146304"/>
+            <a:off x="1920240" y="3410712"/>
+            <a:ext cx="0" cy="128016"/>
           </a:xfrm>
           <a:prstGeom prst="line">
             <a:avLst/>
@@ -3509,8 +3509,8 @@
         </p:nvSpPr>
         <p:spPr>
           <a:xfrm>
-            <a:off x="1234440" y="3758184"/>
-            <a:ext cx="1371600" cy="566928"/>
+            <a:off x="1234440" y="3538728"/>
+            <a:ext cx="1371600" cy="512064"/>
           </a:xfrm>
           <a:prstGeom prst="rect">
             <a:avLst/>
@@ -3529,8 +3529,8 @@
         </p:nvSpPr>
         <p:spPr>
           <a:xfrm>
-            <a:off x="1307592" y="3813048"/>
-            <a:ext cx="1225296" cy="475488"/>
+            <a:off x="1307592" y="3575304"/>
+            <a:ext cx="1225296" cy="438912"/>
           </a:xfrm>
           <a:prstGeom prst="rect">
             <a:avLst/>
@@ -3571,7 +3571,7 @@
         </p:nvSpPr>
         <p:spPr>
           <a:xfrm>
-            <a:off x="3337560" y="3886200"/>
+            <a:off x="3337560" y="3648456"/>
             <a:ext cx="1234440" cy="365760"/>
           </a:xfrm>
           <a:prstGeom prst="rect">
@@ -3607,7 +3607,86 @@
       </p:sp>
       <p:sp>
         <p:nvSpPr>
-          <p:cNvPr id="20" name="Text 18"/>
+          <p:cNvPr id="20" name="Shape 18"/>
+          <p:cNvSpPr/>
+          <p:nvPr/>
+        </p:nvSpPr>
+        <p:spPr>
+          <a:xfrm>
+            <a:off x="502920" y="4233672"/>
+            <a:ext cx="3749040" cy="768096"/>
+          </a:xfrm>
+          <a:prstGeom prst="rect">
+            <a:avLst/>
+          </a:prstGeom>
+          <a:solidFill>
+            <a:srgbClr val="F8F5FA"/>
+          </a:solidFill>
+          <a:ln/>
+        </p:spPr>
+      </p:sp>
+      <p:sp>
+        <p:nvSpPr>
+          <p:cNvPr id="21" name="Text 19"/>
+          <p:cNvSpPr txBox="1"/>
+          <p:nvPr/>
+        </p:nvSpPr>
+        <p:spPr>
+          <a:xfrm>
+            <a:off x="630936" y="4297680"/>
+            <a:ext cx="3520440" cy="658368"/>
+          </a:xfrm>
+          <a:prstGeom prst="rect">
+            <a:avLst/>
+          </a:prstGeom>
+          <a:noFill/>
+          <a:ln/>
+        </p:spPr>
+        <p:txBody>
+          <a:bodyPr wrap="square" lIns="0" tIns="0" rIns="0" bIns="0" rtlCol="0" anchor="t"/>
+          <a:lstStyle/>
+          <a:p>
+            <a:pPr indent="0" marL="0">
+              <a:lnSpc>
+                <a:spcPct val="108000"/>
+              </a:lnSpc>
+              <a:buNone/>
+            </a:pPr>
+            <a:r>
+              <a:rPr lang="en-US" sz="950" b="1" dirty="0">
+                <a:solidFill>
+                  <a:srgbClr val="5B2A86"/>
+                </a:solidFill>
+                <a:latin typeface="Arial" pitchFamily="34" charset="0"/>
+                <a:ea typeface="Arial" pitchFamily="34" charset="-122"/>
+                <a:cs typeface="Arial" pitchFamily="34" charset="-120"/>
+              </a:rPr>
+              <a:t>How ₹1.4 crore is worked out: </a:t>
+            </a:r>
+            <a:pPr indent="0" marL="0">
+              <a:lnSpc>
+                <a:spcPct val="108000"/>
+              </a:lnSpc>
+              <a:buNone/>
+            </a:pPr>
+            <a:r>
+              <a:rPr lang="en-US" sz="950" dirty="0">
+                <a:solidFill>
+                  <a:srgbClr val="17131D"/>
+                </a:solidFill>
+                <a:latin typeface="Arial" pitchFamily="34" charset="0"/>
+                <a:ea typeface="Arial" pitchFamily="34" charset="-122"/>
+                <a:cs typeface="Arial" pitchFamily="34" charset="-120"/>
+              </a:rPr>
+              <a:t>60 h × ₹1.9 lakh per hour = ₹1.14 Cr of lost margin, plus 12 repairs × ₹2.5 lakh = ₹0.30 Cr. Team calculation from the labelled estimates [11].</a:t>
+            </a:r>
+            <a:endParaRPr lang="en-US" sz="950" dirty="0"/>
+          </a:p>
+        </p:txBody>
+      </p:sp>
+      <p:sp>
+        <p:nvSpPr>
+          <p:cNvPr id="22" name="Text 20"/>
           <p:cNvSpPr txBox="1"/>
           <p:nvPr/>
         </p:nvSpPr>
@@ -3649,7 +3728,7 @@
       </p:sp>
       <p:sp>
         <p:nvSpPr>
-          <p:cNvPr id="21" name="Shape 19"/>
+          <p:cNvPr id="23" name="Shape 21"/>
           <p:cNvSpPr/>
           <p:nvPr/>
         </p:nvSpPr>
@@ -3674,7 +3753,7 @@
       </p:sp>
       <p:sp>
         <p:nvSpPr>
-          <p:cNvPr id="22" name="Text 20"/>
+          <p:cNvPr id="24" name="Text 22"/>
           <p:cNvSpPr txBox="1"/>
           <p:nvPr/>
         </p:nvSpPr>
@@ -3708,7 +3787,7 @@
                 <a:ea typeface="Arial" pitchFamily="34" charset="-122"/>
                 <a:cs typeface="Arial" pitchFamily="34" charset="-120"/>
               </a:rPr>
-              <a:t>Bearing or seal degradation begins [4]</a:t>
+              <a:t>Bearing or seal degradation begins [8]</a:t>
             </a:r>
             <a:endParaRPr lang="en-US" sz="1000" dirty="0"/>
           </a:p>
@@ -3716,7 +3795,7 @@
       </p:sp>
       <p:sp>
         <p:nvSpPr>
-          <p:cNvPr id="23" name="Shape 21"/>
+          <p:cNvPr id="25" name="Shape 23"/>
           <p:cNvSpPr/>
           <p:nvPr/>
         </p:nvSpPr>
@@ -3740,7 +3819,7 @@
       </p:sp>
       <p:sp>
         <p:nvSpPr>
-          <p:cNvPr id="24" name="Shape 22"/>
+          <p:cNvPr id="26" name="Shape 24"/>
           <p:cNvSpPr/>
           <p:nvPr/>
         </p:nvSpPr>
@@ -3765,7 +3844,7 @@
       </p:sp>
       <p:sp>
         <p:nvSpPr>
-          <p:cNvPr id="25" name="Text 23"/>
+          <p:cNvPr id="27" name="Text 25"/>
           <p:cNvSpPr txBox="1"/>
           <p:nvPr/>
         </p:nvSpPr>
@@ -3807,7 +3886,7 @@
       </p:sp>
       <p:sp>
         <p:nvSpPr>
-          <p:cNvPr id="26" name="Shape 24"/>
+          <p:cNvPr id="28" name="Shape 26"/>
           <p:cNvSpPr/>
           <p:nvPr/>
         </p:nvSpPr>
@@ -3831,7 +3910,7 @@
       </p:sp>
       <p:sp>
         <p:nvSpPr>
-          <p:cNvPr id="27" name="Shape 25"/>
+          <p:cNvPr id="29" name="Shape 27"/>
           <p:cNvSpPr/>
           <p:nvPr/>
         </p:nvSpPr>
@@ -3856,7 +3935,7 @@
       </p:sp>
       <p:sp>
         <p:nvSpPr>
-          <p:cNvPr id="28" name="Text 26"/>
+          <p:cNvPr id="30" name="Text 28"/>
           <p:cNvSpPr txBox="1"/>
           <p:nvPr/>
         </p:nvSpPr>
@@ -3898,7 +3977,7 @@
       </p:sp>
       <p:sp>
         <p:nvSpPr>
-          <p:cNvPr id="29" name="Shape 27"/>
+          <p:cNvPr id="31" name="Shape 29"/>
           <p:cNvSpPr/>
           <p:nvPr/>
         </p:nvSpPr>
@@ -3922,7 +4001,7 @@
       </p:sp>
       <p:sp>
         <p:nvSpPr>
-          <p:cNvPr id="30" name="Shape 28"/>
+          <p:cNvPr id="32" name="Shape 30"/>
           <p:cNvSpPr/>
           <p:nvPr/>
         </p:nvSpPr>
@@ -3947,7 +4026,7 @@
       </p:sp>
       <p:sp>
         <p:nvSpPr>
-          <p:cNvPr id="31" name="Text 29"/>
+          <p:cNvPr id="33" name="Text 31"/>
           <p:cNvSpPr txBox="1"/>
           <p:nvPr/>
         </p:nvSpPr>
@@ -3989,7 +4068,7 @@
       </p:sp>
       <p:sp>
         <p:nvSpPr>
-          <p:cNvPr id="32" name="Shape 30"/>
+          <p:cNvPr id="34" name="Shape 32"/>
           <p:cNvSpPr/>
           <p:nvPr/>
         </p:nvSpPr>
@@ -4013,7 +4092,7 @@
       </p:sp>
       <p:sp>
         <p:nvSpPr>
-          <p:cNvPr id="33" name="Shape 31"/>
+          <p:cNvPr id="35" name="Shape 33"/>
           <p:cNvSpPr/>
           <p:nvPr/>
         </p:nvSpPr>
@@ -4033,7 +4112,7 @@
       </p:sp>
       <p:sp>
         <p:nvSpPr>
-          <p:cNvPr id="34" name="Text 32"/>
+          <p:cNvPr id="36" name="Text 34"/>
           <p:cNvSpPr txBox="1"/>
           <p:nvPr/>
         </p:nvSpPr>
@@ -4075,7 +4154,7 @@
       </p:sp>
       <p:sp>
         <p:nvSpPr>
-          <p:cNvPr id="35" name="Text 33"/>
+          <p:cNvPr id="37" name="Text 35"/>
           <p:cNvSpPr txBox="1"/>
           <p:nvPr/>
         </p:nvSpPr>
@@ -4117,7 +4196,7 @@
       </p:sp>
       <p:sp>
         <p:nvSpPr>
-          <p:cNvPr id="36" name="Text 34"/>
+          <p:cNvPr id="38" name="Text 36"/>
           <p:cNvSpPr txBox="1"/>
           <p:nvPr/>
         </p:nvSpPr>
@@ -4151,7 +4230,7 @@
                 <a:ea typeface="Arial" pitchFamily="34" charset="-122"/>
                 <a:cs typeface="Arial" pitchFamily="34" charset="-120"/>
               </a:rPr>
-              <a:t>of failure modes in the foundational reliability study for RCM showed no predictable wear-out age [3]</a:t>
+              <a:t>of failure modes in the foundational reliability study for RCM showed no predictable wear-out age [7]</a:t>
             </a:r>
             <a:endParaRPr lang="en-US" sz="1000" dirty="0"/>
           </a:p>
@@ -4159,7 +4238,7 @@
       </p:sp>
       <p:sp>
         <p:nvSpPr>
-          <p:cNvPr id="37" name="Text 35"/>
+          <p:cNvPr id="39" name="Text 37"/>
           <p:cNvSpPr txBox="1"/>
           <p:nvPr/>
         </p:nvSpPr>
@@ -4193,7 +4272,7 @@
                 <a:ea typeface="Arial" pitchFamily="34" charset="-122"/>
                 <a:cs typeface="Arial" pitchFamily="34" charset="-120"/>
               </a:rPr>
-              <a:t>Fixed-interval maintenance cannot anticipate faults that arrive at random. Bearing and seal problems develop over days to weeks [4]; that window is where condition data helps.</a:t>
+              <a:t>Fixed-interval maintenance cannot anticipate faults that arrive at random. Bearing and seal problems develop over days to weeks [8]; that window is where condition data helps.</a:t>
             </a:r>
             <a:endParaRPr lang="en-US" sz="1150" dirty="0"/>
           </a:p>
@@ -4201,7 +4280,7 @@
       </p:sp>
       <p:sp>
         <p:nvSpPr>
-          <p:cNvPr id="38" name="Shape 36"/>
+          <p:cNvPr id="40" name="Shape 38"/>
           <p:cNvSpPr/>
           <p:nvPr/>
         </p:nvSpPr>
@@ -4221,7 +4300,7 @@
       </p:sp>
       <p:sp>
         <p:nvSpPr>
-          <p:cNvPr id="39" name="Text 37"/>
+          <p:cNvPr id="41" name="Text 39"/>
           <p:cNvSpPr txBox="1"/>
           <p:nvPr/>
         </p:nvSpPr>
@@ -4272,7 +4351,7 @@
                 <a:ea typeface="Arial" pitchFamily="34" charset="-122"/>
                 <a:cs typeface="Arial" pitchFamily="34" charset="-120"/>
               </a:rPr>
-              <a:t>flag developing faults on these 25 pumps about two weeks before failure and turn each one into a planned work order.</a:t>
+              <a:t>spot developing faults on these 25 pumps early (the target is two weeks of notice) and alert the engineer with a drafted work order.</a:t>
             </a:r>
             <a:endParaRPr lang="en-US" sz="1100" dirty="0"/>
           </a:p>
@@ -4280,7 +4359,7 @@
       </p:sp>
       <p:sp>
         <p:nvSpPr>
-          <p:cNvPr id="40" name="Shape 38"/>
+          <p:cNvPr id="42" name="Shape 40"/>
           <p:cNvSpPr/>
           <p:nvPr/>
         </p:nvSpPr>
@@ -4303,7 +4382,7 @@
       </p:sp>
       <p:sp>
         <p:nvSpPr>
-          <p:cNvPr id="41" name="Text 39"/>
+          <p:cNvPr id="43" name="Text 41"/>
           <p:cNvSpPr txBox="1"/>
           <p:nvPr/>
         </p:nvSpPr>
@@ -4345,7 +4424,7 @@
       </p:sp>
       <p:sp>
         <p:nvSpPr>
-          <p:cNvPr id="42" name="Text 40"/>
+          <p:cNvPr id="44" name="Text 42"/>
           <p:cNvSpPr txBox="1"/>
           <p:nvPr/>
         </p:nvSpPr>
@@ -4387,7 +4466,7 @@
       </p:sp>
       <p:sp>
         <p:nvSpPr>
-          <p:cNvPr id="43" name="Text 41"/>
+          <p:cNvPr id="45" name="Text 43"/>
           <p:cNvSpPr txBox="1"/>
           <p:nvPr/>
         </p:nvSpPr>
@@ -4429,7 +4508,7 @@
       </p:sp>
       <p:sp>
         <p:nvSpPr>
-          <p:cNvPr id="44" name="Shape 42"/>
+          <p:cNvPr id="46" name="Shape 44"/>
           <p:cNvSpPr/>
           <p:nvPr/>
         </p:nvSpPr>
@@ -4452,7 +4531,7 @@
       </p:sp>
       <p:sp>
         <p:nvSpPr>
-          <p:cNvPr id="45" name="Text 43"/>
+          <p:cNvPr id="47" name="Text 45"/>
           <p:cNvSpPr txBox="1"/>
           <p:nvPr/>
         </p:nvSpPr>
@@ -4494,7 +4573,7 @@
       </p:sp>
       <p:sp>
         <p:nvSpPr>
-          <p:cNvPr id="46" name="Text 44"/>
+          <p:cNvPr id="48" name="Text 46"/>
           <p:cNvSpPr txBox="1"/>
           <p:nvPr/>
         </p:nvSpPr>
@@ -4536,7 +4615,7 @@
       </p:sp>
       <p:sp>
         <p:nvSpPr>
-          <p:cNvPr id="47" name="Text 45"/>
+          <p:cNvPr id="49" name="Text 47"/>
           <p:cNvSpPr txBox="1"/>
           <p:nvPr/>
         </p:nvSpPr>
@@ -4578,7 +4657,7 @@
       </p:sp>
       <p:sp>
         <p:nvSpPr>
-          <p:cNvPr id="48" name="Shape 46"/>
+          <p:cNvPr id="50" name="Shape 48"/>
           <p:cNvSpPr/>
           <p:nvPr/>
         </p:nvSpPr>
@@ -4601,7 +4680,7 @@
       </p:sp>
       <p:sp>
         <p:nvSpPr>
-          <p:cNvPr id="49" name="Text 47"/>
+          <p:cNvPr id="51" name="Text 49"/>
           <p:cNvSpPr txBox="1"/>
           <p:nvPr/>
         </p:nvSpPr>
@@ -4643,7 +4722,7 @@
       </p:sp>
       <p:sp>
         <p:nvSpPr>
-          <p:cNvPr id="50" name="Text 48"/>
+          <p:cNvPr id="52" name="Text 50"/>
           <p:cNvSpPr txBox="1"/>
           <p:nvPr/>
         </p:nvSpPr>
@@ -4685,7 +4764,7 @@
       </p:sp>
       <p:sp>
         <p:nvSpPr>
-          <p:cNvPr id="51" name="Text 49"/>
+          <p:cNvPr id="53" name="Text 51"/>
           <p:cNvSpPr txBox="1"/>
           <p:nvPr/>
         </p:nvSpPr>
@@ -4727,7 +4806,7 @@
       </p:sp>
       <p:sp>
         <p:nvSpPr>
-          <p:cNvPr id="52" name="Shape 50"/>
+          <p:cNvPr id="54" name="Shape 52"/>
           <p:cNvSpPr/>
           <p:nvPr/>
         </p:nvSpPr>
@@ -4750,7 +4829,7 @@
       </p:sp>
       <p:sp>
         <p:nvSpPr>
-          <p:cNvPr id="53" name="Text 51"/>
+          <p:cNvPr id="55" name="Text 53"/>
           <p:cNvSpPr txBox="1"/>
           <p:nvPr/>
         </p:nvSpPr>
@@ -4792,7 +4871,7 @@
       </p:sp>
       <p:sp>
         <p:nvSpPr>
-          <p:cNvPr id="54" name="Text 52"/>
+          <p:cNvPr id="56" name="Text 54"/>
           <p:cNvSpPr txBox="1"/>
           <p:nvPr/>
         </p:nvSpPr>
@@ -4834,7 +4913,7 @@
       </p:sp>
       <p:sp>
         <p:nvSpPr>
-          <p:cNvPr id="55" name="Text 53"/>
+          <p:cNvPr id="57" name="Text 55"/>
           <p:cNvSpPr txBox="1"/>
           <p:nvPr/>
         </p:nvSpPr>
@@ -4876,7 +4955,7 @@
       </p:sp>
       <p:sp>
         <p:nvSpPr>
-          <p:cNvPr id="56" name="Text 54"/>
+          <p:cNvPr id="58" name="Text 56"/>
           <p:cNvSpPr txBox="1"/>
           <p:nvPr/>
         </p:nvSpPr>
@@ -4915,7 +4994,7 @@
       </p:sp>
       <p:sp>
         <p:nvSpPr>
-          <p:cNvPr id="57" name="Text 55"/>
+          <p:cNvPr id="59" name="Text 57"/>
           <p:cNvSpPr txBox="1"/>
           <p:nvPr/>
         </p:nvSpPr>
@@ -8016,7 +8095,7 @@
                 <a:ea typeface="Arial" pitchFamily="34" charset="-122"/>
                 <a:cs typeface="Arial" pitchFamily="34" charset="-120"/>
               </a:rPr>
-              <a:t>Weights in brackets, sum 100. Scores and marks are team judgement based on the documented behaviour of each approach class [2][6].</a:t>
+              <a:t>Weights in brackets, sum 100. Marks are team judgement based on the documented behaviour of each approach class [2][5].</a:t>
             </a:r>
             <a:endParaRPr lang="en-US" sz="850" dirty="0"/>
           </a:p>
@@ -8692,8 +8771,8 @@
         </p:nvSpPr>
         <p:spPr>
           <a:xfrm>
-            <a:off x="7178040" y="3977640"/>
-            <a:ext cx="4480560" cy="502920"/>
+            <a:off x="7178040" y="3904488"/>
+            <a:ext cx="4480560" cy="457200"/>
           </a:xfrm>
           <a:prstGeom prst="rect">
             <a:avLst/>
@@ -8728,7 +8807,49 @@
       </p:sp>
       <p:sp>
         <p:nvSpPr>
-          <p:cNvPr id="30" name="Shape 27"/>
+          <p:cNvPr id="30" name="Text 27"/>
+          <p:cNvSpPr txBox="1"/>
+          <p:nvPr/>
+        </p:nvSpPr>
+        <p:spPr>
+          <a:xfrm>
+            <a:off x="7178040" y="4379976"/>
+            <a:ext cx="4480560" cy="457200"/>
+          </a:xfrm>
+          <a:prstGeom prst="rect">
+            <a:avLst/>
+          </a:prstGeom>
+          <a:noFill/>
+          <a:ln/>
+        </p:spPr>
+        <p:txBody>
+          <a:bodyPr wrap="square" lIns="0" tIns="0" rIns="0" bIns="0" rtlCol="0" anchor="t"/>
+          <a:lstStyle/>
+          <a:p>
+            <a:pPr indent="0" marL="0">
+              <a:lnSpc>
+                <a:spcPct val="105000"/>
+              </a:lnSpc>
+              <a:buNone/>
+            </a:pPr>
+            <a:r>
+              <a:rPr lang="en-US" sz="850" dirty="0">
+                <a:solidFill>
+                  <a:srgbClr val="625D68"/>
+                </a:solidFill>
+                <a:latin typeface="Arial" pitchFamily="34" charset="0"/>
+                <a:ea typeface="Arial" pitchFamily="34" charset="-122"/>
+                <a:cs typeface="Arial" pitchFamily="34" charset="-120"/>
+              </a:rPr>
+              <a:t>How a score is built: each approach gets a 1-to-5 mark per criterion; the score is the weighted average. NAADI: (5×30 + 4×20 + 3×10 + 5×10 + 4×10 + 4×20) / 100 = 4.3.</a:t>
+            </a:r>
+            <a:endParaRPr lang="en-US" sz="850" dirty="0"/>
+          </a:p>
+        </p:txBody>
+      </p:sp>
+      <p:sp>
+        <p:nvSpPr>
+          <p:cNvPr id="31" name="Shape 28"/>
           <p:cNvSpPr/>
           <p:nvPr/>
         </p:nvSpPr>
@@ -8751,7 +8872,7 @@
       </p:sp>
       <p:sp>
         <p:nvSpPr>
-          <p:cNvPr id="31" name="Text 28"/>
+          <p:cNvPr id="32" name="Text 29"/>
           <p:cNvSpPr txBox="1"/>
           <p:nvPr/>
         </p:nvSpPr>
@@ -8793,7 +8914,7 @@
       </p:sp>
       <p:sp>
         <p:nvSpPr>
-          <p:cNvPr id="32" name="Shape 29"/>
+          <p:cNvPr id="33" name="Shape 30"/>
           <p:cNvSpPr/>
           <p:nvPr/>
         </p:nvSpPr>
@@ -8813,7 +8934,7 @@
       </p:sp>
       <p:sp>
         <p:nvSpPr>
-          <p:cNvPr id="33" name="Shape 30"/>
+          <p:cNvPr id="34" name="Shape 31"/>
           <p:cNvSpPr/>
           <p:nvPr/>
         </p:nvSpPr>
@@ -8836,7 +8957,7 @@
       </p:sp>
       <p:sp>
         <p:nvSpPr>
-          <p:cNvPr id="34" name="Shape 31"/>
+          <p:cNvPr id="35" name="Shape 32"/>
           <p:cNvSpPr/>
           <p:nvPr/>
         </p:nvSpPr>
@@ -8859,7 +8980,7 @@
       </p:sp>
       <p:sp>
         <p:nvSpPr>
-          <p:cNvPr id="35" name="Shape 32"/>
+          <p:cNvPr id="36" name="Shape 33"/>
           <p:cNvSpPr/>
           <p:nvPr/>
         </p:nvSpPr>
@@ -8882,7 +9003,7 @@
       </p:sp>
       <p:sp>
         <p:nvSpPr>
-          <p:cNvPr id="36" name="Shape 33"/>
+          <p:cNvPr id="37" name="Shape 34"/>
           <p:cNvSpPr/>
           <p:nvPr/>
         </p:nvSpPr>
@@ -8905,7 +9026,7 @@
       </p:sp>
       <p:sp>
         <p:nvSpPr>
-          <p:cNvPr id="37" name="Text 34"/>
+          <p:cNvPr id="38" name="Text 35"/>
           <p:cNvSpPr txBox="1"/>
           <p:nvPr/>
         </p:nvSpPr>
@@ -8947,7 +9068,7 @@
       </p:sp>
       <p:sp>
         <p:nvSpPr>
-          <p:cNvPr id="38" name="Text 35"/>
+          <p:cNvPr id="39" name="Text 36"/>
           <p:cNvSpPr txBox="1"/>
           <p:nvPr/>
         </p:nvSpPr>
@@ -8989,7 +9110,7 @@
       </p:sp>
       <p:sp>
         <p:nvSpPr>
-          <p:cNvPr id="39" name="Shape 36"/>
+          <p:cNvPr id="40" name="Shape 37"/>
           <p:cNvSpPr/>
           <p:nvPr/>
         </p:nvSpPr>
@@ -9009,7 +9130,7 @@
       </p:sp>
       <p:sp>
         <p:nvSpPr>
-          <p:cNvPr id="40" name="Shape 37"/>
+          <p:cNvPr id="41" name="Shape 38"/>
           <p:cNvSpPr/>
           <p:nvPr/>
         </p:nvSpPr>
@@ -9029,7 +9150,7 @@
       </p:sp>
       <p:sp>
         <p:nvSpPr>
-          <p:cNvPr id="41" name="Shape 38"/>
+          <p:cNvPr id="42" name="Shape 39"/>
           <p:cNvSpPr/>
           <p:nvPr/>
         </p:nvSpPr>
@@ -9049,7 +9170,7 @@
       </p:sp>
       <p:sp>
         <p:nvSpPr>
-          <p:cNvPr id="42" name="Text 39"/>
+          <p:cNvPr id="43" name="Text 40"/>
           <p:cNvSpPr txBox="1"/>
           <p:nvPr/>
         </p:nvSpPr>
@@ -9091,7 +9212,7 @@
       </p:sp>
       <p:sp>
         <p:nvSpPr>
-          <p:cNvPr id="43" name="Text 40"/>
+          <p:cNvPr id="44" name="Text 41"/>
           <p:cNvSpPr txBox="1"/>
           <p:nvPr/>
         </p:nvSpPr>
@@ -9133,7 +9254,7 @@
       </p:sp>
       <p:sp>
         <p:nvSpPr>
-          <p:cNvPr id="44" name="Shape 41"/>
+          <p:cNvPr id="45" name="Shape 42"/>
           <p:cNvSpPr/>
           <p:nvPr/>
         </p:nvSpPr>
@@ -9158,7 +9279,7 @@
       </p:sp>
       <p:sp>
         <p:nvSpPr>
-          <p:cNvPr id="45" name="Shape 42"/>
+          <p:cNvPr id="46" name="Shape 43"/>
           <p:cNvSpPr/>
           <p:nvPr/>
         </p:nvSpPr>
@@ -9178,7 +9299,7 @@
       </p:sp>
       <p:sp>
         <p:nvSpPr>
-          <p:cNvPr id="46" name="Text 43"/>
+          <p:cNvPr id="47" name="Text 44"/>
           <p:cNvSpPr txBox="1"/>
           <p:nvPr/>
         </p:nvSpPr>
@@ -9220,7 +9341,7 @@
       </p:sp>
       <p:sp>
         <p:nvSpPr>
-          <p:cNvPr id="47" name="Text 44"/>
+          <p:cNvPr id="48" name="Text 45"/>
           <p:cNvSpPr txBox="1"/>
           <p:nvPr/>
         </p:nvSpPr>
@@ -9262,7 +9383,7 @@
       </p:sp>
       <p:sp>
         <p:nvSpPr>
-          <p:cNvPr id="48" name="Shape 45"/>
+          <p:cNvPr id="49" name="Shape 46"/>
           <p:cNvSpPr/>
           <p:nvPr/>
         </p:nvSpPr>
@@ -9287,7 +9408,7 @@
       </p:sp>
       <p:sp>
         <p:nvSpPr>
-          <p:cNvPr id="49" name="Shape 46"/>
+          <p:cNvPr id="50" name="Shape 47"/>
           <p:cNvSpPr/>
           <p:nvPr/>
         </p:nvSpPr>
@@ -9311,7 +9432,7 @@
       </p:sp>
       <p:sp>
         <p:nvSpPr>
-          <p:cNvPr id="50" name="Text 47"/>
+          <p:cNvPr id="51" name="Text 48"/>
           <p:cNvSpPr txBox="1"/>
           <p:nvPr/>
         </p:nvSpPr>
@@ -9353,7 +9474,7 @@
       </p:sp>
       <p:sp>
         <p:nvSpPr>
-          <p:cNvPr id="51" name="Text 48"/>
+          <p:cNvPr id="52" name="Text 49"/>
           <p:cNvSpPr txBox="1"/>
           <p:nvPr/>
         </p:nvSpPr>
@@ -9395,7 +9516,7 @@
       </p:sp>
       <p:sp>
         <p:nvSpPr>
-          <p:cNvPr id="52" name="Shape 49"/>
+          <p:cNvPr id="53" name="Shape 50"/>
           <p:cNvSpPr/>
           <p:nvPr/>
         </p:nvSpPr>
@@ -9420,7 +9541,7 @@
       </p:sp>
       <p:sp>
         <p:nvSpPr>
-          <p:cNvPr id="53" name="Shape 50"/>
+          <p:cNvPr id="54" name="Shape 51"/>
           <p:cNvSpPr/>
           <p:nvPr/>
         </p:nvSpPr>
@@ -9445,7 +9566,7 @@
       </p:sp>
       <p:sp>
         <p:nvSpPr>
-          <p:cNvPr id="54" name="Shape 51"/>
+          <p:cNvPr id="55" name="Shape 52"/>
           <p:cNvSpPr/>
           <p:nvPr/>
         </p:nvSpPr>
@@ -9468,7 +9589,7 @@
       </p:sp>
       <p:sp>
         <p:nvSpPr>
-          <p:cNvPr id="55" name="Text 52"/>
+          <p:cNvPr id="56" name="Text 53"/>
           <p:cNvSpPr txBox="1"/>
           <p:nvPr/>
         </p:nvSpPr>
@@ -9510,7 +9631,7 @@
       </p:sp>
       <p:sp>
         <p:nvSpPr>
-          <p:cNvPr id="56" name="Text 53"/>
+          <p:cNvPr id="57" name="Text 54"/>
           <p:cNvSpPr txBox="1"/>
           <p:nvPr/>
         </p:nvSpPr>
@@ -9552,7 +9673,7 @@
       </p:sp>
       <p:sp>
         <p:nvSpPr>
-          <p:cNvPr id="57" name="Text 54"/>
+          <p:cNvPr id="58" name="Text 55"/>
           <p:cNvSpPr txBox="1"/>
           <p:nvPr/>
         </p:nvSpPr>
@@ -9591,7 +9712,7 @@
       </p:sp>
       <p:sp>
         <p:nvSpPr>
-          <p:cNvPr id="58" name="Text 55"/>
+          <p:cNvPr id="59" name="Text 56"/>
           <p:cNvSpPr txBox="1"/>
           <p:nvPr/>
         </p:nvSpPr>
@@ -10176,7 +10297,7 @@
                 <a:ea typeface="Arial" pitchFamily="34" charset="-122"/>
                 <a:cs typeface="Arial" pitchFamily="34" charset="-120"/>
               </a:rPr>
-              <a:t>wireless, on both bearing housings; hardware meeting applicable PESO and IECEx requirements [10]</a:t>
+              <a:t>wireless, on both bearing housings; hardware meeting applicable PESO and IECEx requirements [6]</a:t>
             </a:r>
             <a:endParaRPr lang="en-US" sz="800" dirty="0"/>
           </a:p>
@@ -10442,7 +10563,7 @@
                 <a:ea typeface="Arial" pitchFamily="34" charset="-122"/>
                 <a:cs typeface="Arial" pitchFamily="34" charset="-120"/>
               </a:rPr>
-              <a:t>16 vibration indicators per window, per ISO 13374 [6]</a:t>
+              <a:t>16 vibration indicators per window, per ISO 13374 [5]</a:t>
             </a:r>
             <a:endParaRPr lang="en-US" sz="800" dirty="0"/>
           </a:p>
@@ -10621,7 +10742,7 @@
                 <a:ea typeface="Arial" pitchFamily="34" charset="-122"/>
                 <a:cs typeface="Arial" pitchFamily="34" charset="-120"/>
               </a:rPr>
-              <a:t>per-pump anomaly score and fault type; benchmark result on slide 5 [5]</a:t>
+              <a:t>anomaly score and fault type per pump; benchmark on slide 5 [10]; the pilot tests it on real plant data</a:t>
             </a:r>
             <a:endParaRPr lang="en-US" sz="800" dirty="0"/>
           </a:p>
@@ -10730,7 +10851,7 @@
                 <a:ea typeface="Arial" pitchFamily="34" charset="-122"/>
                 <a:cs typeface="Arial" pitchFamily="34" charset="-120"/>
               </a:rPr>
-              <a:t>trends, alarm zones per ISO 20816-3 [6]</a:t>
+              <a:t>trends, alarm zones per ISO 20816-3 [5]</a:t>
             </a:r>
             <a:endParaRPr lang="en-US" sz="800" dirty="0"/>
           </a:p>
@@ -12800,7 +12921,7 @@
                 <a:ea typeface="Arial" pitchFamily="34" charset="-122"/>
                 <a:cs typeface="Arial" pitchFamily="34" charset="-120"/>
               </a:rPr>
-              <a:t>four-class benchmark accuracy, unseen 3 hp load [5]</a:t>
+              <a:t>four-class benchmark accuracy, unseen 3 hp load [10]</a:t>
             </a:r>
             <a:endParaRPr lang="en-US" sz="850" dirty="0"/>
           </a:p>
@@ -12909,7 +13030,7 @@
                 <a:ea typeface="Arial" pitchFamily="34" charset="-122"/>
                 <a:cs typeface="Arial" pitchFamily="34" charset="-120"/>
               </a:rPr>
-              <a:t>healthy benchmark windows misclassified [5]</a:t>
+              <a:t>healthy benchmark windows misclassified [10]</a:t>
             </a:r>
             <a:endParaRPr lang="en-US" sz="850" dirty="0"/>
           </a:p>
@@ -13018,7 +13139,7 @@
                 <a:ea typeface="Arial" pitchFamily="34" charset="-122"/>
                 <a:cs typeface="Arial" pitchFamily="34" charset="-120"/>
               </a:rPr>
-              <a:t>grouped cross-validation accuracy [5]</a:t>
+              <a:t>grouped cross-validation accuracy [10]</a:t>
             </a:r>
             <a:endParaRPr lang="en-US" sz="850" dirty="0"/>
           </a:p>
@@ -13164,7 +13285,7 @@
                 <a:ea typeface="Arial" pitchFamily="34" charset="-122"/>
                 <a:cs typeface="Arial" pitchFamily="34" charset="-120"/>
               </a:rPr>
-              <a:t>Confusion matrix, unseen 3 hp load [5]</a:t>
+              <a:t>Confusion matrix, unseen 3 hp load [10]</a:t>
             </a:r>
             <a:endParaRPr lang="en-US" sz="1200" dirty="0"/>
           </a:p>
@@ -15031,7 +15152,7 @@
                 <a:ea typeface="Arial" pitchFamily="34" charset="-122"/>
                 <a:cs typeface="Arial" pitchFamily="34" charset="-120"/>
               </a:rPr>
-              <a:t>ISO vibration guidance [6]</a:t>
+              <a:t>ISO vibration guidance [5]</a:t>
             </a:r>
             <a:endParaRPr lang="en-US" sz="950" dirty="0"/>
           </a:p>
@@ -16642,8 +16763,8 @@
         </p:nvSpPr>
         <p:spPr>
           <a:xfrm>
-            <a:off x="8915400" y="1682496"/>
-            <a:ext cx="2715768" cy="274320"/>
+            <a:off x="8915400" y="1664208"/>
+            <a:ext cx="2715768" cy="310896"/>
           </a:xfrm>
           <a:prstGeom prst="rect">
             <a:avLst/>
@@ -16662,7 +16783,7 @@
               <a:buNone/>
             </a:pPr>
             <a:r>
-              <a:rPr lang="en-US" sz="900" dirty="0">
+              <a:rPr lang="en-US" sz="850" dirty="0">
                 <a:solidFill>
                   <a:srgbClr val="625D68"/>
                 </a:solidFill>
@@ -16670,9 +16791,9 @@
                 <a:ea typeface="Arial" pitchFamily="34" charset="-122"/>
                 <a:cs typeface="Arial" pitchFamily="34" charset="-120"/>
               </a:rPr>
-              <a:t>of confirmed developing faults detected</a:t>
-            </a:r>
-            <a:endParaRPr lang="en-US" sz="900" dirty="0"/>
+              <a:t>of the faults maintenance later confirms must have been flagged by NAADI in advance</a:t>
+            </a:r>
+            <a:endParaRPr lang="en-US" sz="850" dirty="0"/>
           </a:p>
         </p:txBody>
       </p:sp>
@@ -16766,8 +16887,8 @@
         </p:nvSpPr>
         <p:spPr>
           <a:xfrm>
-            <a:off x="8915400" y="2249424"/>
-            <a:ext cx="2715768" cy="274320"/>
+            <a:off x="8915400" y="2231136"/>
+            <a:ext cx="2715768" cy="310896"/>
           </a:xfrm>
           <a:prstGeom prst="rect">
             <a:avLst/>
@@ -16786,7 +16907,7 @@
               <a:buNone/>
             </a:pPr>
             <a:r>
-              <a:rPr lang="en-US" sz="900" dirty="0">
+              <a:rPr lang="en-US" sz="850" dirty="0">
                 <a:solidFill>
                   <a:srgbClr val="625D68"/>
                 </a:solidFill>
@@ -16794,9 +16915,9 @@
                 <a:ea typeface="Arial" pitchFamily="34" charset="-122"/>
                 <a:cs typeface="Arial" pitchFamily="34" charset="-120"/>
               </a:rPr>
-              <a:t>warning before functional failure</a:t>
-            </a:r>
-            <a:endParaRPr lang="en-US" sz="900" dirty="0"/>
+              <a:t>of notice: enough to plan the repair into a scheduled window instead of an emergency stop</a:t>
+            </a:r>
+            <a:endParaRPr lang="en-US" sz="850" dirty="0"/>
           </a:p>
         </p:txBody>
       </p:sp>
@@ -16890,8 +17011,8 @@
         </p:nvSpPr>
         <p:spPr>
           <a:xfrm>
-            <a:off x="8915400" y="2816352"/>
-            <a:ext cx="2715768" cy="274320"/>
+            <a:off x="8915400" y="2798064"/>
+            <a:ext cx="2715768" cy="310896"/>
           </a:xfrm>
           <a:prstGeom prst="rect">
             <a:avLst/>
@@ -16910,7 +17031,7 @@
               <a:buNone/>
             </a:pPr>
             <a:r>
-              <a:rPr lang="en-US" sz="900" dirty="0">
+              <a:rPr lang="en-US" sz="850" dirty="0">
                 <a:solidFill>
                   <a:srgbClr val="625D68"/>
                 </a:solidFill>
@@ -16918,9 +17039,9 @@
                 <a:ea typeface="Arial" pitchFamily="34" charset="-122"/>
                 <a:cs typeface="Arial" pitchFamily="34" charset="-120"/>
               </a:rPr>
-              <a:t>false alerts per pump per month</a:t>
-            </a:r>
-            <a:endParaRPr lang="en-US" sz="900" dirty="0"/>
+              <a:t>false alerts per pump per month, so operators keep trusting the alerts</a:t>
+            </a:r>
+            <a:endParaRPr lang="en-US" sz="850" dirty="0"/>
           </a:p>
         </p:txBody>
       </p:sp>
@@ -17014,8 +17135,8 @@
         </p:nvSpPr>
         <p:spPr>
           <a:xfrm>
-            <a:off x="8915400" y="3383280"/>
-            <a:ext cx="2715768" cy="274320"/>
+            <a:off x="8915400" y="3364992"/>
+            <a:ext cx="2715768" cy="310896"/>
           </a:xfrm>
           <a:prstGeom prst="rect">
             <a:avLst/>
@@ -17034,7 +17155,7 @@
               <a:buNone/>
             </a:pPr>
             <a:r>
-              <a:rPr lang="en-US" sz="900" dirty="0">
+              <a:rPr lang="en-US" sz="850" dirty="0">
                 <a:solidFill>
                   <a:srgbClr val="625D68"/>
                 </a:solidFill>
@@ -17044,7 +17165,7 @@
               </a:rPr>
               <a:t>sensor data availability</a:t>
             </a:r>
-            <a:endParaRPr lang="en-US" sz="900" dirty="0"/>
+            <a:endParaRPr lang="en-US" sz="850" dirty="0"/>
           </a:p>
         </p:txBody>
       </p:sp>
@@ -17549,7 +17670,7 @@
                 <a:ea typeface="Arial" pitchFamily="34" charset="-122"/>
                 <a:cs typeface="Arial" pitchFamily="34" charset="-120"/>
               </a:rPr>
-              <a:t>shared deployment across chemical clusters [7][8]</a:t>
+              <a:t>shared deployment across chemical clusters [3][4]</a:t>
             </a:r>
             <a:endParaRPr lang="en-US" sz="900" dirty="0"/>
           </a:p>
@@ -20518,7 +20639,7 @@
                 <a:ea typeface="Arial" pitchFamily="34" charset="-122"/>
                 <a:cs typeface="Arial" pitchFamily="34" charset="-120"/>
               </a:rPr>
-              <a:t>hardware meeting applicable PESO and IECEx requirements [10]</a:t>
+              <a:t>hardware meeting applicable PESO and IECEx requirements [6]</a:t>
             </a:r>
             <a:endParaRPr lang="en-US" sz="850" dirty="0"/>
           </a:p>
@@ -20790,7 +20911,7 @@
                 <a:ea typeface="Arial" pitchFamily="34" charset="-122"/>
                 <a:cs typeface="Arial" pitchFamily="34" charset="-120"/>
               </a:rPr>
-              <a:t>Earlier detection of seal degradation can reduce leak-event risk [4]</a:t>
+              <a:t>Earlier detection of seal degradation can reduce leak-event risk [8]</a:t>
             </a:r>
             <a:endParaRPr lang="en-US" sz="850" dirty="0"/>
           </a:p>
@@ -21381,7 +21502,7 @@
                 <a:ea typeface="Arial" pitchFamily="34" charset="-122"/>
                 <a:cs typeface="Arial" pitchFamily="34" charset="-120"/>
               </a:rPr>
-              <a:t>[7]</a:t>
+              <a:t>[3]</a:t>
             </a:r>
             <a:endParaRPr lang="en-US" sz="1000" dirty="0"/>
           </a:p>
@@ -21489,7 +21610,7 @@
                 <a:ea typeface="Arial" pitchFamily="34" charset="-122"/>
                 <a:cs typeface="Arial" pitchFamily="34" charset="-120"/>
               </a:rPr>
-              <a:t>[8]</a:t>
+              <a:t>[4]</a:t>
             </a:r>
             <a:endParaRPr lang="en-US" sz="1000" dirty="0"/>
           </a:p>
@@ -21639,7 +21760,7 @@
                 <a:ea typeface="Arial" pitchFamily="34" charset="-122"/>
                 <a:cs typeface="Arial" pitchFamily="34" charset="-120"/>
               </a:rPr>
-              <a:t>[6]</a:t>
+              <a:t>[5]</a:t>
             </a:r>
             <a:endParaRPr lang="en-US" sz="1000" dirty="0"/>
           </a:p>
@@ -21747,7 +21868,7 @@
                 <a:ea typeface="Arial" pitchFamily="34" charset="-122"/>
                 <a:cs typeface="Arial" pitchFamily="34" charset="-120"/>
               </a:rPr>
-              <a:t>[10]</a:t>
+              <a:t>[6]</a:t>
             </a:r>
             <a:endParaRPr lang="en-US" sz="1000" dirty="0"/>
           </a:p>
@@ -21897,7 +22018,7 @@
                 <a:ea typeface="Arial" pitchFamily="34" charset="-122"/>
                 <a:cs typeface="Arial" pitchFamily="34" charset="-120"/>
               </a:rPr>
-              <a:t>[3]</a:t>
+              <a:t>[7]</a:t>
             </a:r>
             <a:endParaRPr lang="en-US" sz="1000" dirty="0"/>
           </a:p>
@@ -21981,7 +22102,7 @@
                 <a:ea typeface="Arial" pitchFamily="34" charset="-122"/>
                 <a:cs typeface="Arial" pitchFamily="34" charset="-120"/>
               </a:rPr>
-              <a:t>[4]</a:t>
+              <a:t>[8]</a:t>
             </a:r>
             <a:endParaRPr lang="en-US" sz="1000" dirty="0"/>
           </a:p>
@@ -22215,7 +22336,7 @@
                 <a:ea typeface="Arial" pitchFamily="34" charset="-122"/>
                 <a:cs typeface="Arial" pitchFamily="34" charset="-120"/>
               </a:rPr>
-              <a:t>[5]</a:t>
+              <a:t>[10]</a:t>
             </a:r>
             <a:endParaRPr lang="en-US" sz="1000" dirty="0"/>
           </a:p>

</xml_diff>